<commit_message>
Add secteurs and ROI slides to RAG webinar deck
Extracted "Applications par secteur d'activité" and "Bénéfices et retour
sur investissement" from the Guide Complet RAG doc, styled to match the
deck's existing dark navy/teal card design.

Co-Authored-By: Claude Sonnet 5 <noreply@anthropic.com>
</commit_message>
<xml_diff>
--- a/docs/transferai-admin/Webinaire_Recherche_Documentaire_RAG_Medard_Sery_Soulemane_Konate.pptx
+++ b/docs/transferai-admin/Webinaire_Recherche_Documentaire_RAG_Medard_Sery_Soulemane_Konate.pptx
@@ -8,6 +8,8 @@
     <p:sldId id="256" r:id="rId2"/>
     <p:sldId id="257" r:id="rId3"/>
     <p:sldId id="258" r:id="rId4"/>
+    <p:sldId id="260" r:id="rId11"/>
+    <p:sldId id="261" r:id="rId12"/>
     <p:sldId id="259" r:id="rId5"/>
   </p:sldIdLst>
   <p:notesMasterIdLst>
@@ -4621,6 +4623,1436 @@
 </p:sld>
 </file>
 
+<file path=ppt/slides/slide5.xml><?xml version="1.0" encoding="utf-8"?>
+<p:sld xmlns:a="http://schemas.openxmlformats.org/drawingml/2006/main" xmlns:r="http://schemas.openxmlformats.org/officeDocument/2006/relationships" xmlns:p="http://schemas.openxmlformats.org/presentationml/2006/main">
+  <p:cSld name="Applications par secteur">
+    <p:bg>
+      <p:bgPr>
+        <a:solidFill>
+          <a:srgbClr val="0D1724"/>
+        </a:solidFill>
+      </p:bgPr>
+    </p:bg>
+    <p:spTree>
+      <p:nvGrpSpPr>
+        <p:cNvPr id="1" name=""/>
+        <p:cNvGrpSpPr/>
+        <p:nvPr/>
+      </p:nvGrpSpPr>
+      <p:grpSpPr>
+        <a:xfrm>
+          <a:off x="0" y="0"/>
+          <a:ext cx="0" cy="0"/>
+          <a:chOff x="0" y="0"/>
+          <a:chExt cx="0" cy="0"/>
+        </a:xfrm>
+      </p:grpSpPr>
+      <p:sp>
+        <p:nvSpPr>
+          <p:cNvPr id="2" name="Text"/>
+          <p:cNvSpPr/>
+          <p:nvPr/>
+        </p:nvSpPr>
+        <p:spPr>
+          <a:xfrm>
+            <a:off x="548640" y="411480"/>
+            <a:ext cx="10515600" cy="457200"/>
+          </a:xfrm>
+          <a:prstGeom prst="rect">
+            <a:avLst/>
+          </a:prstGeom>
+          <a:noFill/>
+          <a:ln/>
+        </p:spPr>
+        <p:txBody>
+          <a:bodyPr wrap="square" rtlCol="0" anchor="ctr"/>
+          <a:lstStyle/>
+          <a:p>
+            <a:pPr indent="0" marL="0">
+              <a:buNone/>
+            </a:pPr>
+            <a:r>
+              <a:rPr lang="en-US" sz="2400" b="1" dirty="0">
+                <a:solidFill>
+                  <a:srgbClr val="FFFFFF"/>
+                </a:solidFill>
+                <a:latin typeface="Calibri" pitchFamily="34" charset="0"/>
+                <a:ea typeface="Calibri" pitchFamily="34" charset="-122"/>
+                <a:cs typeface="Calibri" pitchFamily="34" charset="-120"/>
+              </a:rPr>
+              <a:t>Applications par secteur d'activité</a:t>
+            </a:r>
+            <a:endParaRPr lang="en-US" sz="2400" dirty="0"/>
+          </a:p>
+        </p:txBody>
+      </p:sp>
+      <p:sp>
+        <p:nvSpPr>
+          <p:cNvPr id="3" name="Text"/>
+          <p:cNvSpPr/>
+          <p:nvPr/>
+        </p:nvSpPr>
+        <p:spPr>
+          <a:xfrm>
+            <a:off x="548640" y="868680"/>
+            <a:ext cx="10698480" cy="548640"/>
+          </a:xfrm>
+          <a:prstGeom prst="rect">
+            <a:avLst/>
+          </a:prstGeom>
+          <a:noFill/>
+          <a:ln/>
+        </p:spPr>
+        <p:txBody>
+          <a:bodyPr wrap="square" rtlCol="0" anchor="t"/>
+          <a:lstStyle/>
+          <a:p>
+            <a:pPr indent="0" marL="0">
+              <a:buNone/>
+            </a:pPr>
+            <a:r>
+              <a:rPr lang="en-US" sz="1300" dirty="0">
+                <a:solidFill>
+                  <a:srgbClr val="C3D0D8"/>
+                </a:solidFill>
+                <a:latin typeface="Calibri" pitchFamily="34" charset="0"/>
+                <a:ea typeface="Calibri" pitchFamily="34" charset="-122"/>
+                <a:cs typeface="Calibri" pitchFamily="34" charset="-120"/>
+              </a:rPr>
+              <a:t>Le RAG est transversal : implémenté pour un métier, il se réplique presque à l'identique dans un autre.</a:t>
+            </a:r>
+            <a:endParaRPr lang="en-US" sz="1300" dirty="0"/>
+          </a:p>
+        </p:txBody>
+      </p:sp>
+      <p:sp>
+        <p:nvSpPr>
+          <p:cNvPr id="4" name="Shape"/>
+          <p:cNvSpPr/>
+          <p:nvPr/>
+        </p:nvSpPr>
+        <p:spPr>
+          <a:xfrm>
+            <a:off x="548640" y="1450000"/>
+            <a:ext cx="3474720" cy="1750000"/>
+          </a:xfrm>
+          <a:prstGeom prst="roundRect">
+            <a:avLst>
+              <a:gd name="adj" fmla="val 6154"/>
+            </a:avLst>
+          </a:prstGeom>
+          <a:solidFill>
+            <a:srgbClr val="17324D"/>
+          </a:solidFill>
+          <a:ln/>
+        </p:spPr>
+      </p:sp>
+      <p:sp>
+        <p:nvSpPr>
+          <p:cNvPr id="5" name="Text"/>
+          <p:cNvSpPr/>
+          <p:nvPr/>
+        </p:nvSpPr>
+        <p:spPr>
+          <a:xfrm>
+            <a:off x="748640" y="1610000"/>
+            <a:ext cx="3074720" cy="420000"/>
+          </a:xfrm>
+          <a:prstGeom prst="rect">
+            <a:avLst/>
+          </a:prstGeom>
+          <a:noFill/>
+          <a:ln/>
+        </p:spPr>
+        <p:txBody>
+          <a:bodyPr wrap="square" rtlCol="0" anchor="t"/>
+          <a:lstStyle/>
+          <a:p>
+            <a:pPr indent="0" marL="0">
+              <a:buNone/>
+            </a:pPr>
+            <a:r>
+              <a:rPr lang="en-US" sz="1400" b="1" dirty="0">
+                <a:solidFill>
+                  <a:srgbClr val="FFFFFF"/>
+                </a:solidFill>
+                <a:latin typeface="Calibri" pitchFamily="34" charset="0"/>
+                <a:ea typeface="Calibri" pitchFamily="34" charset="-122"/>
+                <a:cs typeface="Calibri" pitchFamily="34" charset="-120"/>
+              </a:rPr>
+              <a:t>Ressources Humaines</a:t>
+            </a:r>
+            <a:endParaRPr lang="en-US" sz="1400" dirty="0"/>
+          </a:p>
+        </p:txBody>
+      </p:sp>
+      <p:sp>
+        <p:nvSpPr>
+          <p:cNvPr id="6" name="Text"/>
+          <p:cNvSpPr/>
+          <p:nvPr/>
+        </p:nvSpPr>
+        <p:spPr>
+          <a:xfrm>
+            <a:off x="748640" y="2010000"/>
+            <a:ext cx="3074720" cy="1050000"/>
+          </a:xfrm>
+          <a:prstGeom prst="rect">
+            <a:avLst/>
+          </a:prstGeom>
+          <a:noFill/>
+          <a:ln/>
+        </p:spPr>
+        <p:txBody>
+          <a:bodyPr wrap="square" rtlCol="0" anchor="t"/>
+          <a:lstStyle/>
+          <a:p>
+            <a:pPr indent="0" marL="0">
+              <a:buNone/>
+            </a:pPr>
+            <a:r>
+              <a:rPr lang="en-US" sz="1000" dirty="0">
+                <a:solidFill>
+                  <a:srgbClr val="C3D0D8"/>
+                </a:solidFill>
+                <a:latin typeface="Calibri" pitchFamily="34" charset="0"/>
+                <a:ea typeface="Calibri" pitchFamily="34" charset="-122"/>
+                <a:cs typeface="Calibri" pitchFamily="34" charset="-120"/>
+              </a:rPr>
+              <a:t>Convention collective et procédures RH en libre-service ; intégration accélérée des nouveaux employés.</a:t>
+            </a:r>
+            <a:endParaRPr lang="en-US" sz="1000" dirty="0"/>
+          </a:p>
+        </p:txBody>
+      </p:sp>
+      <p:sp>
+        <p:nvSpPr>
+          <p:cNvPr id="7" name="Shape"/>
+          <p:cNvSpPr/>
+          <p:nvPr/>
+        </p:nvSpPr>
+        <p:spPr>
+          <a:xfrm>
+            <a:off x="4251960" y="1450000"/>
+            <a:ext cx="3474720" cy="1750000"/>
+          </a:xfrm>
+          <a:prstGeom prst="roundRect">
+            <a:avLst>
+              <a:gd name="adj" fmla="val 6154"/>
+            </a:avLst>
+          </a:prstGeom>
+          <a:solidFill>
+            <a:srgbClr val="17324D"/>
+          </a:solidFill>
+          <a:ln/>
+        </p:spPr>
+      </p:sp>
+      <p:sp>
+        <p:nvSpPr>
+          <p:cNvPr id="8" name="Text"/>
+          <p:cNvSpPr/>
+          <p:nvPr/>
+        </p:nvSpPr>
+        <p:spPr>
+          <a:xfrm>
+            <a:off x="4451960" y="1610000"/>
+            <a:ext cx="3074720" cy="420000"/>
+          </a:xfrm>
+          <a:prstGeom prst="rect">
+            <a:avLst/>
+          </a:prstGeom>
+          <a:noFill/>
+          <a:ln/>
+        </p:spPr>
+        <p:txBody>
+          <a:bodyPr wrap="square" rtlCol="0" anchor="t"/>
+          <a:lstStyle/>
+          <a:p>
+            <a:pPr indent="0" marL="0">
+              <a:buNone/>
+            </a:pPr>
+            <a:r>
+              <a:rPr lang="en-US" sz="1400" b="1" dirty="0">
+                <a:solidFill>
+                  <a:srgbClr val="FFFFFF"/>
+                </a:solidFill>
+                <a:latin typeface="Calibri" pitchFamily="34" charset="0"/>
+                <a:ea typeface="Calibri" pitchFamily="34" charset="-122"/>
+                <a:cs typeface="Calibri" pitchFamily="34" charset="-120"/>
+              </a:rPr>
+              <a:t>Finance &amp; Banques</a:t>
+            </a:r>
+            <a:endParaRPr lang="en-US" sz="1400" dirty="0"/>
+          </a:p>
+        </p:txBody>
+      </p:sp>
+      <p:sp>
+        <p:nvSpPr>
+          <p:cNvPr id="9" name="Text"/>
+          <p:cNvSpPr/>
+          <p:nvPr/>
+        </p:nvSpPr>
+        <p:spPr>
+          <a:xfrm>
+            <a:off x="4451960" y="2010000"/>
+            <a:ext cx="3074720" cy="1050000"/>
+          </a:xfrm>
+          <a:prstGeom prst="rect">
+            <a:avLst/>
+          </a:prstGeom>
+          <a:noFill/>
+          <a:ln/>
+        </p:spPr>
+        <p:txBody>
+          <a:bodyPr wrap="square" rtlCol="0" anchor="t"/>
+          <a:lstStyle/>
+          <a:p>
+            <a:pPr indent="0" marL="0">
+              <a:buNone/>
+            </a:pPr>
+            <a:r>
+              <a:rPr lang="en-US" sz="1000" dirty="0">
+                <a:solidFill>
+                  <a:srgbClr val="C3D0D8"/>
+                </a:solidFill>
+                <a:latin typeface="Calibri" pitchFamily="34" charset="0"/>
+                <a:ea typeface="Calibri" pitchFamily="34" charset="-122"/>
+                <a:cs typeface="Calibri" pitchFamily="34" charset="-120"/>
+              </a:rPr>
+              <a:t>Conformité UEMOA/BCEAO et clauses contractuelles retrouvées en secondes ; pré-clôture et audit accélérés.</a:t>
+            </a:r>
+            <a:endParaRPr lang="en-US" sz="1000" dirty="0"/>
+          </a:p>
+        </p:txBody>
+      </p:sp>
+      <p:sp>
+        <p:nvSpPr>
+          <p:cNvPr id="10" name="Shape"/>
+          <p:cNvSpPr/>
+          <p:nvPr/>
+        </p:nvSpPr>
+        <p:spPr>
+          <a:xfrm>
+            <a:off x="7955280" y="1450000"/>
+            <a:ext cx="3474720" cy="1750000"/>
+          </a:xfrm>
+          <a:prstGeom prst="roundRect">
+            <a:avLst>
+              <a:gd name="adj" fmla="val 6154"/>
+            </a:avLst>
+          </a:prstGeom>
+          <a:solidFill>
+            <a:srgbClr val="17324D"/>
+          </a:solidFill>
+          <a:ln/>
+        </p:spPr>
+      </p:sp>
+      <p:sp>
+        <p:nvSpPr>
+          <p:cNvPr id="11" name="Text"/>
+          <p:cNvSpPr/>
+          <p:nvPr/>
+        </p:nvSpPr>
+        <p:spPr>
+          <a:xfrm>
+            <a:off x="8155280" y="1610000"/>
+            <a:ext cx="3074720" cy="420000"/>
+          </a:xfrm>
+          <a:prstGeom prst="rect">
+            <a:avLst/>
+          </a:prstGeom>
+          <a:noFill/>
+          <a:ln/>
+        </p:spPr>
+        <p:txBody>
+          <a:bodyPr wrap="square" rtlCol="0" anchor="t"/>
+          <a:lstStyle/>
+          <a:p>
+            <a:pPr indent="0" marL="0">
+              <a:buNone/>
+            </a:pPr>
+            <a:r>
+              <a:rPr lang="en-US" sz="1400" b="1" dirty="0">
+                <a:solidFill>
+                  <a:srgbClr val="FFFFFF"/>
+                </a:solidFill>
+                <a:latin typeface="Calibri" pitchFamily="34" charset="0"/>
+                <a:ea typeface="Calibri" pitchFamily="34" charset="-122"/>
+                <a:cs typeface="Calibri" pitchFamily="34" charset="-120"/>
+              </a:rPr>
+              <a:t>Transport &amp; Logistique</a:t>
+            </a:r>
+            <a:endParaRPr lang="en-US" sz="1400" dirty="0"/>
+          </a:p>
+        </p:txBody>
+      </p:sp>
+      <p:sp>
+        <p:nvSpPr>
+          <p:cNvPr id="12" name="Text"/>
+          <p:cNvSpPr/>
+          <p:nvPr/>
+        </p:nvSpPr>
+        <p:spPr>
+          <a:xfrm>
+            <a:off x="8155280" y="2010000"/>
+            <a:ext cx="3074720" cy="1050000"/>
+          </a:xfrm>
+          <a:prstGeom prst="rect">
+            <a:avLst/>
+          </a:prstGeom>
+          <a:noFill/>
+          <a:ln/>
+        </p:spPr>
+        <p:txBody>
+          <a:bodyPr wrap="square" rtlCol="0" anchor="t"/>
+          <a:lstStyle/>
+          <a:p>
+            <a:pPr indent="0" marL="0">
+              <a:buNone/>
+            </a:pPr>
+            <a:r>
+              <a:rPr lang="en-US" sz="1000" dirty="0">
+                <a:solidFill>
+                  <a:srgbClr val="C3D0D8"/>
+                </a:solidFill>
+                <a:latin typeface="Calibri" pitchFamily="34" charset="0"/>
+                <a:ea typeface="Calibri" pitchFamily="34" charset="-122"/>
+                <a:cs typeface="Calibri" pitchFamily="34" charset="-120"/>
+              </a:rPr>
+              <a:t>Procédures de sécurité et exigences douanières par corridor ; formation des chauffeurs accélérée.</a:t>
+            </a:r>
+            <a:endParaRPr lang="en-US" sz="1000" dirty="0"/>
+          </a:p>
+        </p:txBody>
+      </p:sp>
+      <p:sp>
+        <p:nvSpPr>
+          <p:cNvPr id="13" name="Shape"/>
+          <p:cNvSpPr/>
+          <p:nvPr/>
+        </p:nvSpPr>
+        <p:spPr>
+          <a:xfrm>
+            <a:off x="548640" y="3360000"/>
+            <a:ext cx="3474720" cy="1750000"/>
+          </a:xfrm>
+          <a:prstGeom prst="roundRect">
+            <a:avLst>
+              <a:gd name="adj" fmla="val 6154"/>
+            </a:avLst>
+          </a:prstGeom>
+          <a:solidFill>
+            <a:srgbClr val="17324D"/>
+          </a:solidFill>
+          <a:ln/>
+        </p:spPr>
+      </p:sp>
+      <p:sp>
+        <p:nvSpPr>
+          <p:cNvPr id="14" name="Text"/>
+          <p:cNvSpPr/>
+          <p:nvPr/>
+        </p:nvSpPr>
+        <p:spPr>
+          <a:xfrm>
+            <a:off x="748640" y="3520000"/>
+            <a:ext cx="3074720" cy="420000"/>
+          </a:xfrm>
+          <a:prstGeom prst="rect">
+            <a:avLst/>
+          </a:prstGeom>
+          <a:noFill/>
+          <a:ln/>
+        </p:spPr>
+        <p:txBody>
+          <a:bodyPr wrap="square" rtlCol="0" anchor="t"/>
+          <a:lstStyle/>
+          <a:p>
+            <a:pPr indent="0" marL="0">
+              <a:buNone/>
+            </a:pPr>
+            <a:r>
+              <a:rPr lang="en-US" sz="1400" b="1" dirty="0">
+                <a:solidFill>
+                  <a:srgbClr val="FFFFFF"/>
+                </a:solidFill>
+                <a:latin typeface="Calibri" pitchFamily="34" charset="0"/>
+                <a:ea typeface="Calibri" pitchFamily="34" charset="-122"/>
+                <a:cs typeface="Calibri" pitchFamily="34" charset="-120"/>
+              </a:rPr>
+              <a:t>Santé</a:t>
+            </a:r>
+            <a:endParaRPr lang="en-US" sz="1400" dirty="0"/>
+          </a:p>
+        </p:txBody>
+      </p:sp>
+      <p:sp>
+        <p:nvSpPr>
+          <p:cNvPr id="15" name="Text"/>
+          <p:cNvSpPr/>
+          <p:nvPr/>
+        </p:nvSpPr>
+        <p:spPr>
+          <a:xfrm>
+            <a:off x="748640" y="3920000"/>
+            <a:ext cx="3074720" cy="1050000"/>
+          </a:xfrm>
+          <a:prstGeom prst="rect">
+            <a:avLst/>
+          </a:prstGeom>
+          <a:noFill/>
+          <a:ln/>
+        </p:spPr>
+        <p:txBody>
+          <a:bodyPr wrap="square" rtlCol="0" anchor="t"/>
+          <a:lstStyle/>
+          <a:p>
+            <a:pPr indent="0" marL="0">
+              <a:buNone/>
+            </a:pPr>
+            <a:r>
+              <a:rPr lang="en-US" sz="1000" dirty="0">
+                <a:solidFill>
+                  <a:srgbClr val="C3D0D8"/>
+                </a:solidFill>
+                <a:latin typeface="Calibri" pitchFamily="34" charset="0"/>
+                <a:ea typeface="Calibri" pitchFamily="34" charset="-122"/>
+                <a:cs typeface="Calibri" pitchFamily="34" charset="-120"/>
+              </a:rPr>
+              <a:t>Protocoles et posologies retrouvés avec la source citée ; mise à jour immédiate des pratiques.</a:t>
+            </a:r>
+            <a:endParaRPr lang="en-US" sz="1000" dirty="0"/>
+          </a:p>
+        </p:txBody>
+      </p:sp>
+      <p:sp>
+        <p:nvSpPr>
+          <p:cNvPr id="16" name="Shape"/>
+          <p:cNvSpPr/>
+          <p:nvPr/>
+        </p:nvSpPr>
+        <p:spPr>
+          <a:xfrm>
+            <a:off x="4251960" y="3360000"/>
+            <a:ext cx="3474720" cy="1750000"/>
+          </a:xfrm>
+          <a:prstGeom prst="roundRect">
+            <a:avLst>
+              <a:gd name="adj" fmla="val 6154"/>
+            </a:avLst>
+          </a:prstGeom>
+          <a:solidFill>
+            <a:srgbClr val="17324D"/>
+          </a:solidFill>
+          <a:ln/>
+        </p:spPr>
+      </p:sp>
+      <p:sp>
+        <p:nvSpPr>
+          <p:cNvPr id="17" name="Text"/>
+          <p:cNvSpPr/>
+          <p:nvPr/>
+        </p:nvSpPr>
+        <p:spPr>
+          <a:xfrm>
+            <a:off x="4451960" y="3520000"/>
+            <a:ext cx="3074720" cy="420000"/>
+          </a:xfrm>
+          <a:prstGeom prst="rect">
+            <a:avLst/>
+          </a:prstGeom>
+          <a:noFill/>
+          <a:ln/>
+        </p:spPr>
+        <p:txBody>
+          <a:bodyPr wrap="square" rtlCol="0" anchor="t"/>
+          <a:lstStyle/>
+          <a:p>
+            <a:pPr indent="0" marL="0">
+              <a:buNone/>
+            </a:pPr>
+            <a:r>
+              <a:rPr lang="en-US" sz="1400" b="1" dirty="0">
+                <a:solidFill>
+                  <a:srgbClr val="FFFFFF"/>
+                </a:solidFill>
+                <a:latin typeface="Calibri" pitchFamily="34" charset="0"/>
+                <a:ea typeface="Calibri" pitchFamily="34" charset="-122"/>
+                <a:cs typeface="Calibri" pitchFamily="34" charset="-120"/>
+              </a:rPr>
+              <a:t>Éducation &amp; Formation</a:t>
+            </a:r>
+            <a:endParaRPr lang="en-US" sz="1400" dirty="0"/>
+          </a:p>
+        </p:txBody>
+      </p:sp>
+      <p:sp>
+        <p:nvSpPr>
+          <p:cNvPr id="18" name="Text"/>
+          <p:cNvSpPr/>
+          <p:nvPr/>
+        </p:nvSpPr>
+        <p:spPr>
+          <a:xfrm>
+            <a:off x="4451960" y="3920000"/>
+            <a:ext cx="3074720" cy="1050000"/>
+          </a:xfrm>
+          <a:prstGeom prst="rect">
+            <a:avLst/>
+          </a:prstGeom>
+          <a:noFill/>
+          <a:ln/>
+        </p:spPr>
+        <p:txBody>
+          <a:bodyPr wrap="square" rtlCol="0" anchor="t"/>
+          <a:lstStyle/>
+          <a:p>
+            <a:pPr indent="0" marL="0">
+              <a:buNone/>
+            </a:pPr>
+            <a:r>
+              <a:rPr lang="en-US" sz="1000" dirty="0">
+                <a:solidFill>
+                  <a:srgbClr val="C3D0D8"/>
+                </a:solidFill>
+                <a:latin typeface="Calibri" pitchFamily="34" charset="0"/>
+                <a:ea typeface="Calibri" pitchFamily="34" charset="-122"/>
+                <a:cs typeface="Calibri" pitchFamily="34" charset="-120"/>
+              </a:rPr>
+              <a:t>Réponses sourcées aux apprenants à partir des vrais supports de cours, disponibles hors des heures de cours.</a:t>
+            </a:r>
+            <a:endParaRPr lang="en-US" sz="1000" dirty="0"/>
+          </a:p>
+        </p:txBody>
+      </p:sp>
+      <p:sp>
+        <p:nvSpPr>
+          <p:cNvPr id="19" name="Shape"/>
+          <p:cNvSpPr/>
+          <p:nvPr/>
+        </p:nvSpPr>
+        <p:spPr>
+          <a:xfrm>
+            <a:off x="7955280" y="3360000"/>
+            <a:ext cx="3474720" cy="1750000"/>
+          </a:xfrm>
+          <a:prstGeom prst="roundRect">
+            <a:avLst>
+              <a:gd name="adj" fmla="val 6154"/>
+            </a:avLst>
+          </a:prstGeom>
+          <a:solidFill>
+            <a:srgbClr val="17324D"/>
+          </a:solidFill>
+          <a:ln/>
+        </p:spPr>
+      </p:sp>
+      <p:sp>
+        <p:nvSpPr>
+          <p:cNvPr id="20" name="Text"/>
+          <p:cNvSpPr/>
+          <p:nvPr/>
+        </p:nvSpPr>
+        <p:spPr>
+          <a:xfrm>
+            <a:off x="8155280" y="3520000"/>
+            <a:ext cx="3074720" cy="420000"/>
+          </a:xfrm>
+          <a:prstGeom prst="rect">
+            <a:avLst/>
+          </a:prstGeom>
+          <a:noFill/>
+          <a:ln/>
+        </p:spPr>
+        <p:txBody>
+          <a:bodyPr wrap="square" rtlCol="0" anchor="t"/>
+          <a:lstStyle/>
+          <a:p>
+            <a:pPr indent="0" marL="0">
+              <a:buNone/>
+            </a:pPr>
+            <a:r>
+              <a:rPr lang="en-US" sz="1400" b="1" dirty="0">
+                <a:solidFill>
+                  <a:srgbClr val="FFFFFF"/>
+                </a:solidFill>
+                <a:latin typeface="Calibri" pitchFamily="34" charset="0"/>
+                <a:ea typeface="Calibri" pitchFamily="34" charset="-122"/>
+                <a:cs typeface="Calibri" pitchFamily="34" charset="-120"/>
+              </a:rPr>
+              <a:t>Juridique &amp; Conformité</a:t>
+            </a:r>
+            <a:endParaRPr lang="en-US" sz="1400" dirty="0"/>
+          </a:p>
+        </p:txBody>
+      </p:sp>
+      <p:sp>
+        <p:nvSpPr>
+          <p:cNvPr id="21" name="Text"/>
+          <p:cNvSpPr/>
+          <p:nvPr/>
+        </p:nvSpPr>
+        <p:spPr>
+          <a:xfrm>
+            <a:off x="8155280" y="3920000"/>
+            <a:ext cx="3074720" cy="1050000"/>
+          </a:xfrm>
+          <a:prstGeom prst="rect">
+            <a:avLst/>
+          </a:prstGeom>
+          <a:noFill/>
+          <a:ln/>
+        </p:spPr>
+        <p:txBody>
+          <a:bodyPr wrap="square" rtlCol="0" anchor="t"/>
+          <a:lstStyle/>
+          <a:p>
+            <a:pPr indent="0" marL="0">
+              <a:buNone/>
+            </a:pPr>
+            <a:r>
+              <a:rPr lang="en-US" sz="1000" dirty="0">
+                <a:solidFill>
+                  <a:srgbClr val="C3D0D8"/>
+                </a:solidFill>
+                <a:latin typeface="Calibri" pitchFamily="34" charset="0"/>
+                <a:ea typeface="Calibri" pitchFamily="34" charset="-122"/>
+                <a:cs typeface="Calibri" pitchFamily="34" charset="-120"/>
+              </a:rPr>
+              <a:t>Clauses et précédents retrouvés instantanément ; interprétation uniforme entre collaborateurs.</a:t>
+            </a:r>
+            <a:endParaRPr lang="en-US" sz="1000" dirty="0"/>
+          </a:p>
+        </p:txBody>
+      </p:sp>
+      <p:sp>
+        <p:nvSpPr>
+          <p:cNvPr id="22" name="Text"/>
+          <p:cNvSpPr/>
+          <p:nvPr/>
+        </p:nvSpPr>
+        <p:spPr>
+          <a:xfrm>
+            <a:off x="548640" y="5320000"/>
+            <a:ext cx="10881360" cy="400000"/>
+          </a:xfrm>
+          <a:prstGeom prst="rect">
+            <a:avLst/>
+          </a:prstGeom>
+          <a:noFill/>
+          <a:ln/>
+        </p:spPr>
+        <p:txBody>
+          <a:bodyPr wrap="square" rtlCol="0" anchor="ctr"/>
+          <a:lstStyle/>
+          <a:p>
+            <a:pPr indent="0" marL="0">
+              <a:buNone/>
+            </a:pPr>
+            <a:r>
+              <a:rPr lang="en-US" sz="1050" i="1" dirty="0">
+                <a:solidFill>
+                  <a:srgbClr val="8598A0"/>
+                </a:solidFill>
+                <a:latin typeface="Calibri" pitchFamily="34" charset="0"/>
+                <a:ea typeface="Calibri" pitchFamily="34" charset="-122"/>
+                <a:cs typeface="Calibri" pitchFamily="34" charset="-120"/>
+              </a:rPr>
+              <a:t>Et au-delà : secteur public, support client, toute organisation avec une documentation structurée.</a:t>
+            </a:r>
+            <a:endParaRPr lang="en-US" sz="1050" dirty="0"/>
+          </a:p>
+        </p:txBody>
+      </p:sp>
+      <p:sp>
+        <p:nvSpPr>
+          <p:cNvPr id="23" name="Text"/>
+          <p:cNvSpPr/>
+          <p:nvPr/>
+        </p:nvSpPr>
+        <p:spPr>
+          <a:xfrm>
+            <a:off x="457200" y="6473952"/>
+            <a:ext cx="7315200" cy="274320"/>
+          </a:xfrm>
+          <a:prstGeom prst="rect">
+            <a:avLst/>
+          </a:prstGeom>
+          <a:noFill/>
+          <a:ln/>
+        </p:spPr>
+        <p:txBody>
+          <a:bodyPr wrap="square" rtlCol="0" anchor="ctr"/>
+          <a:lstStyle/>
+          <a:p>
+            <a:pPr indent="0" marL="0">
+              <a:buNone/>
+            </a:pPr>
+            <a:r>
+              <a:rPr lang="en-US" sz="900" dirty="0">
+                <a:solidFill>
+                  <a:srgbClr val="8598A0"/>
+                </a:solidFill>
+                <a:latin typeface="Calibri" pitchFamily="34" charset="0"/>
+                <a:ea typeface="Calibri" pitchFamily="34" charset="-122"/>
+                <a:cs typeface="Calibri" pitchFamily="34" charset="-120"/>
+              </a:rPr>
+              <a:t>TransferAI Africa  •  Recherche Documentaire Intelligente (RAG)</a:t>
+            </a:r>
+            <a:endParaRPr lang="en-US" sz="900" dirty="0"/>
+          </a:p>
+        </p:txBody>
+      </p:sp>
+      <p:sp>
+        <p:nvSpPr>
+          <p:cNvPr id="24" name="Text"/>
+          <p:cNvSpPr/>
+          <p:nvPr/>
+        </p:nvSpPr>
+        <p:spPr>
+          <a:xfrm>
+            <a:off x="8503920" y="6473952"/>
+            <a:ext cx="3200400" cy="274320"/>
+          </a:xfrm>
+          <a:prstGeom prst="rect">
+            <a:avLst/>
+          </a:prstGeom>
+          <a:noFill/>
+          <a:ln/>
+        </p:spPr>
+        <p:txBody>
+          <a:bodyPr wrap="square" rtlCol="0" anchor="ctr"/>
+          <a:lstStyle/>
+          <a:p>
+            <a:pPr algn="r" indent="0" marL="0">
+              <a:buNone/>
+            </a:pPr>
+            <a:r>
+              <a:rPr lang="en-US" sz="900" dirty="0">
+                <a:solidFill>
+                  <a:srgbClr val="8598A0"/>
+                </a:solidFill>
+                <a:latin typeface="Calibri" pitchFamily="34" charset="0"/>
+                <a:ea typeface="Calibri" pitchFamily="34" charset="-122"/>
+                <a:cs typeface="Calibri" pitchFamily="34" charset="-120"/>
+              </a:rPr>
+              <a:t>18 juillet 2026</a:t>
+            </a:r>
+            <a:endParaRPr lang="en-US" sz="900" dirty="0"/>
+          </a:p>
+        </p:txBody>
+      </p:sp>
+    </p:spTree>
+  </p:cSld>
+  <p:clrMapOvr>
+    <a:masterClrMapping/>
+  </p:clrMapOvr>
+</p:sld>
+</file>
+
+<file path=ppt/slides/slide6.xml><?xml version="1.0" encoding="utf-8"?>
+<p:sld xmlns:a="http://schemas.openxmlformats.org/drawingml/2006/main" xmlns:r="http://schemas.openxmlformats.org/officeDocument/2006/relationships" xmlns:p="http://schemas.openxmlformats.org/presentationml/2006/main">
+  <p:cSld name="Benefices et ROI">
+    <p:bg>
+      <p:bgPr>
+        <a:solidFill>
+          <a:srgbClr val="0D1724"/>
+        </a:solidFill>
+      </p:bgPr>
+    </p:bg>
+    <p:spTree>
+      <p:nvGrpSpPr>
+        <p:cNvPr id="1" name=""/>
+        <p:cNvGrpSpPr/>
+        <p:nvPr/>
+      </p:nvGrpSpPr>
+      <p:grpSpPr>
+        <a:xfrm>
+          <a:off x="0" y="0"/>
+          <a:ext cx="0" cy="0"/>
+          <a:chOff x="0" y="0"/>
+          <a:chExt cx="0" cy="0"/>
+        </a:xfrm>
+      </p:grpSpPr>
+      <p:sp>
+        <p:nvSpPr>
+          <p:cNvPr id="2" name="Text"/>
+          <p:cNvSpPr/>
+          <p:nvPr/>
+        </p:nvSpPr>
+        <p:spPr>
+          <a:xfrm>
+            <a:off x="548640" y="411480"/>
+            <a:ext cx="10515600" cy="457200"/>
+          </a:xfrm>
+          <a:prstGeom prst="rect">
+            <a:avLst/>
+          </a:prstGeom>
+          <a:noFill/>
+          <a:ln/>
+        </p:spPr>
+        <p:txBody>
+          <a:bodyPr wrap="square" rtlCol="0" anchor="ctr"/>
+          <a:lstStyle/>
+          <a:p>
+            <a:pPr indent="0" marL="0">
+              <a:buNone/>
+            </a:pPr>
+            <a:r>
+              <a:rPr lang="en-US" sz="2400" b="1" dirty="0">
+                <a:solidFill>
+                  <a:srgbClr val="FFFFFF"/>
+                </a:solidFill>
+                <a:latin typeface="Calibri" pitchFamily="34" charset="0"/>
+                <a:ea typeface="Calibri" pitchFamily="34" charset="-122"/>
+                <a:cs typeface="Calibri" pitchFamily="34" charset="-120"/>
+              </a:rPr>
+              <a:t>Bénéfices &amp; retour sur investissement</a:t>
+            </a:r>
+            <a:endParaRPr lang="en-US" sz="2400" dirty="0"/>
+          </a:p>
+        </p:txBody>
+      </p:sp>
+      <p:sp>
+        <p:nvSpPr>
+          <p:cNvPr id="3" name="Text"/>
+          <p:cNvSpPr/>
+          <p:nvPr/>
+        </p:nvSpPr>
+        <p:spPr>
+          <a:xfrm>
+            <a:off x="548640" y="868680"/>
+            <a:ext cx="10698480" cy="548640"/>
+          </a:xfrm>
+          <a:prstGeom prst="rect">
+            <a:avLst/>
+          </a:prstGeom>
+          <a:noFill/>
+          <a:ln/>
+        </p:spPr>
+        <p:txBody>
+          <a:bodyPr wrap="square" rtlCol="0" anchor="t"/>
+          <a:lstStyle/>
+          <a:p>
+            <a:pPr indent="0" marL="0">
+              <a:buNone/>
+            </a:pPr>
+            <a:r>
+              <a:rPr lang="en-US" sz="1300" dirty="0">
+                <a:solidFill>
+                  <a:srgbClr val="C3D0D8"/>
+                </a:solidFill>
+                <a:latin typeface="Calibri" pitchFamily="34" charset="0"/>
+                <a:ea typeface="Calibri" pitchFamily="34" charset="-122"/>
+                <a:cs typeface="Calibri" pitchFamily="34" charset="-120"/>
+              </a:rPr>
+              <a:t>Ce n'est pas théorique : c'est ce que produit, en conditions réelles, le système TransferAI Africa.</a:t>
+            </a:r>
+            <a:endParaRPr lang="en-US" sz="1300" dirty="0"/>
+          </a:p>
+        </p:txBody>
+      </p:sp>
+      <p:sp>
+        <p:nvSpPr>
+          <p:cNvPr id="4" name="Shape"/>
+          <p:cNvSpPr/>
+          <p:nvPr/>
+        </p:nvSpPr>
+        <p:spPr>
+          <a:xfrm>
+            <a:off x="548640" y="1450000"/>
+            <a:ext cx="3474720" cy="1850000"/>
+          </a:xfrm>
+          <a:prstGeom prst="roundRect">
+            <a:avLst>
+              <a:gd name="adj" fmla="val 6154"/>
+            </a:avLst>
+          </a:prstGeom>
+          <a:solidFill>
+            <a:srgbClr val="0F3540"/>
+          </a:solidFill>
+          <a:ln w="6350">
+            <a:solidFill>
+              <a:srgbClr val="3FC1D0"/>
+            </a:solidFill>
+            <a:prstDash val="solid"/>
+          </a:ln>
+        </p:spPr>
+      </p:sp>
+      <p:sp>
+        <p:nvSpPr>
+          <p:cNvPr id="5" name="Text"/>
+          <p:cNvSpPr/>
+          <p:nvPr/>
+        </p:nvSpPr>
+        <p:spPr>
+          <a:xfrm>
+            <a:off x="748640" y="1610000"/>
+            <a:ext cx="3074720" cy="420000"/>
+          </a:xfrm>
+          <a:prstGeom prst="rect">
+            <a:avLst/>
+          </a:prstGeom>
+          <a:noFill/>
+          <a:ln/>
+        </p:spPr>
+        <p:txBody>
+          <a:bodyPr wrap="square" rtlCol="0" anchor="t"/>
+          <a:lstStyle/>
+          <a:p>
+            <a:pPr indent="0" marL="0">
+              <a:buNone/>
+            </a:pPr>
+            <a:r>
+              <a:rPr lang="en-US" sz="1600" b="1" dirty="0">
+                <a:solidFill>
+                  <a:srgbClr val="3FC1D0"/>
+                </a:solidFill>
+                <a:latin typeface="Calibri" pitchFamily="34" charset="0"/>
+                <a:ea typeface="Calibri" pitchFamily="34" charset="-122"/>
+                <a:cs typeface="Calibri" pitchFamily="34" charset="-120"/>
+              </a:rPr>
+              <a:t>Précision</a:t>
+            </a:r>
+            <a:endParaRPr lang="en-US" sz="1600" dirty="0"/>
+          </a:p>
+        </p:txBody>
+      </p:sp>
+      <p:sp>
+        <p:nvSpPr>
+          <p:cNvPr id="6" name="Text"/>
+          <p:cNvSpPr/>
+          <p:nvPr/>
+        </p:nvSpPr>
+        <p:spPr>
+          <a:xfrm>
+            <a:off x="748640" y="2070000"/>
+            <a:ext cx="3074720" cy="1090000"/>
+          </a:xfrm>
+          <a:prstGeom prst="rect">
+            <a:avLst/>
+          </a:prstGeom>
+          <a:noFill/>
+          <a:ln/>
+        </p:spPr>
+        <p:txBody>
+          <a:bodyPr wrap="square" rtlCol="0" anchor="t"/>
+          <a:lstStyle/>
+          <a:p>
+            <a:pPr indent="0" marL="0">
+              <a:buNone/>
+            </a:pPr>
+            <a:r>
+              <a:rPr lang="en-US" sz="1000" dirty="0">
+                <a:solidFill>
+                  <a:srgbClr val="C3D0D8"/>
+                </a:solidFill>
+                <a:latin typeface="Calibri" pitchFamily="34" charset="0"/>
+                <a:ea typeface="Calibri" pitchFamily="34" charset="-122"/>
+                <a:cs typeface="Calibri" pitchFamily="34" charset="-120"/>
+              </a:rPr>
+              <a:t>La réponse s'appuie sur de vrais documents de l'organisation, pas sur des connaissances générales potentiellement fausses ou obsolètes.</a:t>
+            </a:r>
+            <a:endParaRPr lang="en-US" sz="1000" dirty="0"/>
+          </a:p>
+        </p:txBody>
+      </p:sp>
+      <p:sp>
+        <p:nvSpPr>
+          <p:cNvPr id="7" name="Shape"/>
+          <p:cNvSpPr/>
+          <p:nvPr/>
+        </p:nvSpPr>
+        <p:spPr>
+          <a:xfrm>
+            <a:off x="4251960" y="1450000"/>
+            <a:ext cx="3474720" cy="1850000"/>
+          </a:xfrm>
+          <a:prstGeom prst="roundRect">
+            <a:avLst>
+              <a:gd name="adj" fmla="val 6154"/>
+            </a:avLst>
+          </a:prstGeom>
+          <a:solidFill>
+            <a:srgbClr val="0F3540"/>
+          </a:solidFill>
+          <a:ln w="6350">
+            <a:solidFill>
+              <a:srgbClr val="3FC1D0"/>
+            </a:solidFill>
+            <a:prstDash val="solid"/>
+          </a:ln>
+        </p:spPr>
+      </p:sp>
+      <p:sp>
+        <p:nvSpPr>
+          <p:cNvPr id="8" name="Text"/>
+          <p:cNvSpPr/>
+          <p:nvPr/>
+        </p:nvSpPr>
+        <p:spPr>
+          <a:xfrm>
+            <a:off x="4451960" y="1610000"/>
+            <a:ext cx="3074720" cy="420000"/>
+          </a:xfrm>
+          <a:prstGeom prst="rect">
+            <a:avLst/>
+          </a:prstGeom>
+          <a:noFill/>
+          <a:ln/>
+        </p:spPr>
+        <p:txBody>
+          <a:bodyPr wrap="square" rtlCol="0" anchor="t"/>
+          <a:lstStyle/>
+          <a:p>
+            <a:pPr indent="0" marL="0">
+              <a:buNone/>
+            </a:pPr>
+            <a:r>
+              <a:rPr lang="en-US" sz="1600" b="1" dirty="0">
+                <a:solidFill>
+                  <a:srgbClr val="3FC1D0"/>
+                </a:solidFill>
+                <a:latin typeface="Calibri" pitchFamily="34" charset="0"/>
+                <a:ea typeface="Calibri" pitchFamily="34" charset="-122"/>
+                <a:cs typeface="Calibri" pitchFamily="34" charset="-120"/>
+              </a:rPr>
+              <a:t>Fraîcheur</a:t>
+            </a:r>
+            <a:endParaRPr lang="en-US" sz="1600" dirty="0"/>
+          </a:p>
+        </p:txBody>
+      </p:sp>
+      <p:sp>
+        <p:nvSpPr>
+          <p:cNvPr id="9" name="Text"/>
+          <p:cNvSpPr/>
+          <p:nvPr/>
+        </p:nvSpPr>
+        <p:spPr>
+          <a:xfrm>
+            <a:off x="4451960" y="2070000"/>
+            <a:ext cx="3074720" cy="1090000"/>
+          </a:xfrm>
+          <a:prstGeom prst="rect">
+            <a:avLst/>
+          </a:prstGeom>
+          <a:noFill/>
+          <a:ln/>
+        </p:spPr>
+        <p:txBody>
+          <a:bodyPr wrap="square" rtlCol="0" anchor="t"/>
+          <a:lstStyle/>
+          <a:p>
+            <a:pPr indent="0" marL="0">
+              <a:buNone/>
+            </a:pPr>
+            <a:r>
+              <a:rPr lang="en-US" sz="1000" dirty="0">
+                <a:solidFill>
+                  <a:srgbClr val="C3D0D8"/>
+                </a:solidFill>
+                <a:latin typeface="Calibri" pitchFamily="34" charset="0"/>
+                <a:ea typeface="Calibri" pitchFamily="34" charset="-122"/>
+                <a:cs typeface="Calibri" pitchFamily="34" charset="-120"/>
+              </a:rPr>
+              <a:t>Il suffit d'ajouter ou de mettre à jour un document pour que l'IA en tienne compte — pas besoin de réentraîner un modèle.</a:t>
+            </a:r>
+            <a:endParaRPr lang="en-US" sz="1000" dirty="0"/>
+          </a:p>
+        </p:txBody>
+      </p:sp>
+      <p:sp>
+        <p:nvSpPr>
+          <p:cNvPr id="10" name="Shape"/>
+          <p:cNvSpPr/>
+          <p:nvPr/>
+        </p:nvSpPr>
+        <p:spPr>
+          <a:xfrm>
+            <a:off x="7955280" y="1450000"/>
+            <a:ext cx="3474720" cy="1850000"/>
+          </a:xfrm>
+          <a:prstGeom prst="roundRect">
+            <a:avLst>
+              <a:gd name="adj" fmla="val 6154"/>
+            </a:avLst>
+          </a:prstGeom>
+          <a:solidFill>
+            <a:srgbClr val="0F3540"/>
+          </a:solidFill>
+          <a:ln w="6350">
+            <a:solidFill>
+              <a:srgbClr val="3FC1D0"/>
+            </a:solidFill>
+            <a:prstDash val="solid"/>
+          </a:ln>
+        </p:spPr>
+      </p:sp>
+      <p:sp>
+        <p:nvSpPr>
+          <p:cNvPr id="11" name="Text"/>
+          <p:cNvSpPr/>
+          <p:nvPr/>
+        </p:nvSpPr>
+        <p:spPr>
+          <a:xfrm>
+            <a:off x="8155280" y="1610000"/>
+            <a:ext cx="3074720" cy="420000"/>
+          </a:xfrm>
+          <a:prstGeom prst="rect">
+            <a:avLst/>
+          </a:prstGeom>
+          <a:noFill/>
+          <a:ln/>
+        </p:spPr>
+        <p:txBody>
+          <a:bodyPr wrap="square" rtlCol="0" anchor="t"/>
+          <a:lstStyle/>
+          <a:p>
+            <a:pPr indent="0" marL="0">
+              <a:buNone/>
+            </a:pPr>
+            <a:r>
+              <a:rPr lang="en-US" sz="1600" b="1" dirty="0">
+                <a:solidFill>
+                  <a:srgbClr val="3FC1D0"/>
+                </a:solidFill>
+                <a:latin typeface="Calibri" pitchFamily="34" charset="0"/>
+                <a:ea typeface="Calibri" pitchFamily="34" charset="-122"/>
+                <a:cs typeface="Calibri" pitchFamily="34" charset="-120"/>
+              </a:rPr>
+              <a:t>Traçabilité</a:t>
+            </a:r>
+            <a:endParaRPr lang="en-US" sz="1600" dirty="0"/>
+          </a:p>
+        </p:txBody>
+      </p:sp>
+      <p:sp>
+        <p:nvSpPr>
+          <p:cNvPr id="12" name="Text"/>
+          <p:cNvSpPr/>
+          <p:nvPr/>
+        </p:nvSpPr>
+        <p:spPr>
+          <a:xfrm>
+            <a:off x="8155280" y="2070000"/>
+            <a:ext cx="3074720" cy="1090000"/>
+          </a:xfrm>
+          <a:prstGeom prst="rect">
+            <a:avLst/>
+          </a:prstGeom>
+          <a:noFill/>
+          <a:ln/>
+        </p:spPr>
+        <p:txBody>
+          <a:bodyPr wrap="square" rtlCol="0" anchor="t"/>
+          <a:lstStyle/>
+          <a:p>
+            <a:pPr indent="0" marL="0">
+              <a:buNone/>
+            </a:pPr>
+            <a:r>
+              <a:rPr lang="en-US" sz="1000" dirty="0">
+                <a:solidFill>
+                  <a:srgbClr val="C3D0D8"/>
+                </a:solidFill>
+                <a:latin typeface="Calibri" pitchFamily="34" charset="0"/>
+                <a:ea typeface="Calibri" pitchFamily="34" charset="-122"/>
+                <a:cs typeface="Calibri" pitchFamily="34" charset="-120"/>
+              </a:rPr>
+              <a:t>Chaque réponse peut être reliée à sa source documentaire, ce qui permet de vérifier et de faire confiance à l'information fournie.</a:t>
+            </a:r>
+            <a:endParaRPr lang="en-US" sz="1000" dirty="0"/>
+          </a:p>
+        </p:txBody>
+      </p:sp>
+      <p:sp>
+        <p:nvSpPr>
+          <p:cNvPr id="13" name="Shape"/>
+          <p:cNvSpPr/>
+          <p:nvPr/>
+        </p:nvSpPr>
+        <p:spPr>
+          <a:xfrm>
+            <a:off x="548640" y="3600000"/>
+            <a:ext cx="10881360" cy="1554480"/>
+          </a:xfrm>
+          <a:prstGeom prst="roundRect">
+            <a:avLst>
+              <a:gd name="adj" fmla="val 4706"/>
+            </a:avLst>
+          </a:prstGeom>
+          <a:solidFill>
+            <a:srgbClr val="3FC1D0"/>
+          </a:solidFill>
+          <a:ln/>
+        </p:spPr>
+      </p:sp>
+      <p:sp>
+        <p:nvSpPr>
+          <p:cNvPr id="14" name="Text"/>
+          <p:cNvSpPr/>
+          <p:nvPr/>
+        </p:nvSpPr>
+        <p:spPr>
+          <a:xfrm>
+            <a:off x="822960" y="3737160"/>
+            <a:ext cx="10332720" cy="548640"/>
+          </a:xfrm>
+          <a:prstGeom prst="rect">
+            <a:avLst/>
+          </a:prstGeom>
+          <a:noFill/>
+          <a:ln/>
+        </p:spPr>
+        <p:txBody>
+          <a:bodyPr wrap="square" rtlCol="0" anchor="t"/>
+          <a:lstStyle/>
+          <a:p>
+            <a:pPr indent="0" marL="0">
+              <a:buNone/>
+            </a:pPr>
+            <a:r>
+              <a:rPr lang="en-US" sz="1300" b="1" dirty="0">
+                <a:solidFill>
+                  <a:srgbClr val="0D1724"/>
+                </a:solidFill>
+                <a:latin typeface="Calibri" pitchFamily="34" charset="0"/>
+                <a:ea typeface="Calibri" pitchFamily="34" charset="-122"/>
+                <a:cs typeface="Calibri" pitchFamily="34" charset="-120"/>
+              </a:rPr>
+              <a:t>Objectif réaliste : plusieurs heures de temps productif récupérées par semaine, par collaborateur exposé à des recherches documentaires fréquentes.</a:t>
+            </a:r>
+            <a:endParaRPr lang="en-US" sz="1300" dirty="0"/>
+          </a:p>
+        </p:txBody>
+      </p:sp>
+      <p:sp>
+        <p:nvSpPr>
+          <p:cNvPr id="15" name="Text"/>
+          <p:cNvSpPr/>
+          <p:nvPr/>
+        </p:nvSpPr>
+        <p:spPr>
+          <a:xfrm>
+            <a:off x="822960" y="4423000"/>
+            <a:ext cx="10332720" cy="640000"/>
+          </a:xfrm>
+          <a:prstGeom prst="rect">
+            <a:avLst/>
+          </a:prstGeom>
+          <a:noFill/>
+          <a:ln/>
+        </p:spPr>
+        <p:txBody>
+          <a:bodyPr wrap="square" rtlCol="0" anchor="t"/>
+          <a:lstStyle/>
+          <a:p>
+            <a:pPr indent="0" marL="0">
+              <a:buNone/>
+            </a:pPr>
+            <a:r>
+              <a:rPr lang="en-US" sz="1050" i="1" dirty="0">
+                <a:solidFill>
+                  <a:srgbClr val="0A2F35"/>
+                </a:solidFill>
+                <a:latin typeface="Calibri" pitchFamily="34" charset="0"/>
+                <a:ea typeface="Calibri" pitchFamily="34" charset="-122"/>
+                <a:cs typeface="Calibri" pitchFamily="34" charset="-120"/>
+              </a:rPr>
+              <a:t>Ces ordres de grandeur restent à valider spécifiquement pour chaque organisation — c'est précisément l'objet d'un premier diagnostic avant tout déploiement.</a:t>
+            </a:r>
+            <a:endParaRPr lang="en-US" sz="1050" dirty="0"/>
+          </a:p>
+        </p:txBody>
+      </p:sp>
+      <p:sp>
+        <p:nvSpPr>
+          <p:cNvPr id="16" name="Text"/>
+          <p:cNvSpPr/>
+          <p:nvPr/>
+        </p:nvSpPr>
+        <p:spPr>
+          <a:xfrm>
+            <a:off x="457200" y="6473952"/>
+            <a:ext cx="7315200" cy="274320"/>
+          </a:xfrm>
+          <a:prstGeom prst="rect">
+            <a:avLst/>
+          </a:prstGeom>
+          <a:noFill/>
+          <a:ln/>
+        </p:spPr>
+        <p:txBody>
+          <a:bodyPr wrap="square" rtlCol="0" anchor="ctr"/>
+          <a:lstStyle/>
+          <a:p>
+            <a:pPr indent="0" marL="0">
+              <a:buNone/>
+            </a:pPr>
+            <a:r>
+              <a:rPr lang="en-US" sz="900" dirty="0">
+                <a:solidFill>
+                  <a:srgbClr val="8598A0"/>
+                </a:solidFill>
+                <a:latin typeface="Calibri" pitchFamily="34" charset="0"/>
+                <a:ea typeface="Calibri" pitchFamily="34" charset="-122"/>
+                <a:cs typeface="Calibri" pitchFamily="34" charset="-120"/>
+              </a:rPr>
+              <a:t>TransferAI Africa  •  Recherche Documentaire Intelligente (RAG)</a:t>
+            </a:r>
+            <a:endParaRPr lang="en-US" sz="900" dirty="0"/>
+          </a:p>
+        </p:txBody>
+      </p:sp>
+      <p:sp>
+        <p:nvSpPr>
+          <p:cNvPr id="17" name="Text"/>
+          <p:cNvSpPr/>
+          <p:nvPr/>
+        </p:nvSpPr>
+        <p:spPr>
+          <a:xfrm>
+            <a:off x="8503920" y="6473952"/>
+            <a:ext cx="3200400" cy="274320"/>
+          </a:xfrm>
+          <a:prstGeom prst="rect">
+            <a:avLst/>
+          </a:prstGeom>
+          <a:noFill/>
+          <a:ln/>
+        </p:spPr>
+        <p:txBody>
+          <a:bodyPr wrap="square" rtlCol="0" anchor="ctr"/>
+          <a:lstStyle/>
+          <a:p>
+            <a:pPr algn="r" indent="0" marL="0">
+              <a:buNone/>
+            </a:pPr>
+            <a:r>
+              <a:rPr lang="en-US" sz="900" dirty="0">
+                <a:solidFill>
+                  <a:srgbClr val="8598A0"/>
+                </a:solidFill>
+                <a:latin typeface="Calibri" pitchFamily="34" charset="0"/>
+                <a:ea typeface="Calibri" pitchFamily="34" charset="-122"/>
+                <a:cs typeface="Calibri" pitchFamily="34" charset="-120"/>
+              </a:rPr>
+              <a:t>18 juillet 2026</a:t>
+            </a:r>
+            <a:endParaRPr lang="en-US" sz="900" dirty="0"/>
+          </a:p>
+        </p:txBody>
+      </p:sp>
+    </p:spTree>
+  </p:cSld>
+  <p:clrMapOvr>
+    <a:masterClrMapping/>
+  </p:clrMapOvr>
+</p:sld>
+</file>
+
 <file path=ppt/theme/theme1.xml><?xml version="1.0" encoding="utf-8"?>
 <a:theme xmlns:a="http://schemas.openxmlformats.org/drawingml/2006/main" name="Office Theme">
   <a:themeElements>

</xml_diff>